<commit_message>
Update changed and new files
</commit_message>
<xml_diff>
--- a/PPTs/REVIEW - 2.pptx
+++ b/PPTs/REVIEW - 2.pptx
@@ -54,7 +54,7 @@
   <pc:docChgLst>
     <pc:chgData name="Manoj Reddy Tetala" userId="d0a499fca1df3751" providerId="LiveId" clId="{844F9A02-E604-4125-9813-311D2C5B92A5}"/>
     <pc:docChg chg="undo custSel delSld modSld">
-      <pc:chgData name="Manoj Reddy Tetala" userId="d0a499fca1df3751" providerId="LiveId" clId="{844F9A02-E604-4125-9813-311D2C5B92A5}" dt="2026-10-29T14:55:10.002" v="118" actId="47"/>
+      <pc:chgData name="Manoj Reddy Tetala" userId="d0a499fca1df3751" providerId="LiveId" clId="{844F9A02-E604-4125-9813-311D2C5B92A5}" dt="2026-10-30T04:12:36.374" v="144" actId="20577"/>
       <pc:docMkLst>
         <pc:docMk/>
       </pc:docMkLst>
@@ -74,7 +74,7 @@
         </pc:spChg>
       </pc:sldChg>
       <pc:sldChg chg="modSp mod">
-        <pc:chgData name="Manoj Reddy Tetala" userId="d0a499fca1df3751" providerId="LiveId" clId="{844F9A02-E604-4125-9813-311D2C5B92A5}" dt="2026-10-26T10:17:09.998" v="72"/>
+        <pc:chgData name="Manoj Reddy Tetala" userId="d0a499fca1df3751" providerId="LiveId" clId="{844F9A02-E604-4125-9813-311D2C5B92A5}" dt="2026-10-30T04:12:36.374" v="144" actId="20577"/>
         <pc:sldMkLst>
           <pc:docMk/>
           <pc:sldMk cId="0" sldId="257"/>
@@ -85,6 +85,14 @@
             <pc:docMk/>
             <pc:sldMk cId="0" sldId="257"/>
             <ac:spMk id="10" creationId="{00000000-0000-0000-0000-000000000000}"/>
+          </ac:spMkLst>
+        </pc:spChg>
+        <pc:spChg chg="mod">
+          <ac:chgData name="Manoj Reddy Tetala" userId="d0a499fca1df3751" providerId="LiveId" clId="{844F9A02-E604-4125-9813-311D2C5B92A5}" dt="2026-10-30T04:12:36.374" v="144" actId="20577"/>
+          <ac:spMkLst>
+            <pc:docMk/>
+            <pc:sldMk cId="0" sldId="257"/>
+            <ac:spMk id="11" creationId="{00000000-0000-0000-0000-000000000000}"/>
           </ac:spMkLst>
         </pc:spChg>
       </pc:sldChg>
@@ -1482,7 +1490,7 @@
             <a:fld id="{0B419B0A-DB98-47ED-A0D2-B47FD394FE07}" type="datetimeFigureOut">
               <a:rPr lang="en-IN" smtClean="0"/>
               <a:pPr/>
-              <a:t>29-10-2026</a:t>
+              <a:t>30-10-2026</a:t>
             </a:fld>
             <a:endParaRPr lang="en-IN"/>
           </a:p>
@@ -2097,7 +2105,7 @@
             <a:fld id="{1D8BD707-D9CF-40AE-B4C6-C98DA3205C09}" type="datetimeFigureOut">
               <a:rPr lang="en-US"/>
               <a:pPr/>
-              <a:t>10/29/2026</a:t>
+              <a:t>10/30/2026</a:t>
             </a:fld>
             <a:endParaRPr lang="en-US"/>
           </a:p>
@@ -2277,7 +2285,7 @@
             <a:fld id="{1D8BD707-D9CF-40AE-B4C6-C98DA3205C09}" type="datetimeFigureOut">
               <a:rPr lang="en-US"/>
               <a:pPr/>
-              <a:t>10/29/2026</a:t>
+              <a:t>10/30/2026</a:t>
             </a:fld>
             <a:endParaRPr lang="en-US"/>
           </a:p>
@@ -2494,7 +2502,7 @@
             <a:fld id="{1D8BD707-D9CF-40AE-B4C6-C98DA3205C09}" type="datetimeFigureOut">
               <a:rPr lang="en-US"/>
               <a:pPr/>
-              <a:t>10/29/2026</a:t>
+              <a:t>10/30/2026</a:t>
             </a:fld>
             <a:endParaRPr lang="en-US"/>
           </a:p>
@@ -2645,7 +2653,7 @@
             <a:fld id="{1D8BD707-D9CF-40AE-B4C6-C98DA3205C09}" type="datetimeFigureOut">
               <a:rPr lang="en-US"/>
               <a:pPr/>
-              <a:t>10/29/2026</a:t>
+              <a:t>10/30/2026</a:t>
             </a:fld>
             <a:endParaRPr lang="en-US"/>
           </a:p>
@@ -2961,7 +2969,7 @@
             <a:fld id="{1D8BD707-D9CF-40AE-B4C6-C98DA3205C09}" type="datetimeFigureOut">
               <a:rPr lang="en-US"/>
               <a:pPr/>
-              <a:t>10/29/2026</a:t>
+              <a:t>10/30/2026</a:t>
             </a:fld>
             <a:endParaRPr lang="en-US"/>
           </a:p>
@@ -3189,7 +3197,7 @@
             <a:fld id="{1D8BD707-D9CF-40AE-B4C6-C98DA3205C09}" type="datetimeFigureOut">
               <a:rPr lang="en-US"/>
               <a:pPr/>
-              <a:t>10/29/2026</a:t>
+              <a:t>10/30/2026</a:t>
             </a:fld>
             <a:endParaRPr lang="en-US"/>
           </a:p>
@@ -7053,7 +7061,7 @@
         <p:spPr>
           <a:xfrm>
             <a:off x="1219200" y="1676400"/>
-            <a:ext cx="7132320" cy="5052665"/>
+            <a:ext cx="7132320" cy="4593565"/>
           </a:xfrm>
           <a:prstGeom prst="rect">
             <a:avLst/>
@@ -7242,28 +7250,19 @@
                 <a:latin typeface="Times New Roman" panose="02020603050405020304" pitchFamily="18" charset="0"/>
                 <a:cs typeface="Times New Roman" panose="02020603050405020304" pitchFamily="18" charset="0"/>
               </a:rPr>
-              <a:t>• Key Insights &amp; Analysis</a:t>
-            </a:r>
-          </a:p>
-          <a:p>
-            <a:pPr algn="l">
-              <a:spcAft>
-                <a:spcPts val="700"/>
-              </a:spcAft>
-              <a:defRPr sz="2000" b="0">
-                <a:solidFill>
-                  <a:srgbClr val="2D2D2D"/>
-                </a:solidFill>
-                <a:latin typeface="Aptos"/>
-              </a:defRPr>
-            </a:pPr>
-            <a:r>
-              <a:rPr sz="2400" dirty="0">
+              <a:t>• Key Insights </a:t>
+            </a:r>
+            <a:r>
+              <a:rPr sz="2400">
                 <a:latin typeface="Times New Roman" panose="02020603050405020304" pitchFamily="18" charset="0"/>
                 <a:cs typeface="Times New Roman" panose="02020603050405020304" pitchFamily="18" charset="0"/>
               </a:rPr>
-              <a:t>• Implementation Workflow</a:t>
-            </a:r>
+              <a:t>&amp; Analysis</a:t>
+            </a:r>
+            <a:endParaRPr sz="2400" dirty="0">
+              <a:latin typeface="Times New Roman" panose="02020603050405020304" pitchFamily="18" charset="0"/>
+              <a:cs typeface="Times New Roman" panose="02020603050405020304" pitchFamily="18" charset="0"/>
+            </a:endParaRPr>
           </a:p>
           <a:p>
             <a:pPr algn="l">

</xml_diff>